<commit_message>
Polish FYP reports, PPT, and viva pack for demo clarity.
Simplify architecture wording, pin Demo B FX at 20, speed CSV imports, and document frameworks, FxRateCache, and presenter notes.

Co-authored-by: Cursor <cursoragent@cursor.com>
</commit_message>
<xml_diff>
--- a/docs/report/Tranz-Algo_Final_Year_Project_Presentation_2026.pptx
+++ b/docs/report/Tranz-Algo_Final_Year_Project_Presentation_2026.pptx
@@ -21,6 +21,7 @@
     <p:sldId id="269" r:id="rId20"/>
     <p:sldId id="270" r:id="rId21"/>
     <p:sldId id="271" r:id="rId22"/>
+    <p:sldId id="272" r:id="rId23"/>
   </p:sldIdLst>
   <p:sldSz cx="12191695" cy="6858000" type="screen4x3"/>
   <p:notesSz cx="6858000" cy="9144000"/>
@@ -3576,7 +3577,7 @@
                 </a:solidFill>
                 <a:latin typeface="Calibri"/>
               </a:rPr>
-              <a:t>10 / 16</a:t>
+              <a:t>10 / 17</a:t>
             </a:r>
           </a:p>
         </p:txBody>
@@ -3610,7 +3611,7 @@
                 </a:solidFill>
                 <a:latin typeface="Calibri"/>
               </a:rPr>
-              <a:t>Key Implementation Details</a:t>
+              <a:t>System Components / Modules</a:t>
             </a:r>
           </a:p>
         </p:txBody>
@@ -3623,8 +3624,8 @@
         </p:nvSpPr>
         <p:spPr>
           <a:xfrm>
-            <a:off x="548640" y="1005840"/>
-            <a:ext cx="10972800" cy="2286000"/>
+            <a:off x="548640" y="1051560"/>
+            <a:ext cx="10972800" cy="4754880"/>
           </a:xfrm>
           <a:prstGeom prst="rect">
             <a:avLst/>
@@ -3643,13 +3644,22 @@
               </a:spcAft>
             </a:pPr>
             <a:r>
-              <a:rPr sz="1800" b="0">
+              <a:rPr sz="1900" b="1">
+                <a:solidFill>
+                  <a:srgbClr val="102A38"/>
+                </a:solidFill>
+                <a:latin typeface="Calibri"/>
+              </a:rPr>
+              <a:t>•  Auth: </a:t>
+            </a:r>
+            <a:r>
+              <a:rPr sz="1900" b="0">
                 <a:solidFill>
                   <a:srgbClr val="000000"/>
                 </a:solidFill>
                 <a:latin typeface="Calibri"/>
               </a:rPr>
-              <a:t>•  React web admin instead of React Native — prioritise desk costing MVP</a:t>
+              <a:t>JWT login / Create account</a:t>
             </a:r>
           </a:p>
           <a:p>
@@ -3659,13 +3669,22 @@
               </a:spcAft>
             </a:pPr>
             <a:r>
-              <a:rPr sz="1800" b="0">
+              <a:rPr sz="1900" b="1">
+                <a:solidFill>
+                  <a:srgbClr val="102A38"/>
+                </a:solidFill>
+                <a:latin typeface="Calibri"/>
+              </a:rPr>
+              <a:t>•  Products: </a:t>
+            </a:r>
+            <a:r>
+              <a:rPr sz="1900" b="0">
                 <a:solidFill>
                   <a:srgbClr val="000000"/>
                 </a:solidFill>
                 <a:latin typeface="Calibri"/>
               </a:rPr>
-              <a:t>•  Strategy (modes/allocation) · Facade (commit) · Chain (FX providers)</a:t>
+              <a:t>catalogue + CSV import (+ optional auto SKU)</a:t>
             </a:r>
           </a:p>
           <a:p>
@@ -3675,22 +3694,22 @@
               </a:spcAft>
             </a:pPr>
             <a:r>
-              <a:rPr sz="1800" b="1">
+              <a:rPr sz="1900" b="1">
                 <a:solidFill>
                   <a:srgbClr val="102A38"/>
                 </a:solidFill>
                 <a:latin typeface="Calibri"/>
               </a:rPr>
-              <a:t>•  CSV import drives Demo A/B: </a:t>
-            </a:r>
-            <a:r>
-              <a:rPr sz="1800" b="0">
+              <a:t>•  Shipments: </a:t>
+            </a:r>
+            <a:r>
+              <a:rPr sz="1900" b="0">
                 <a:solidFill>
                   <a:srgbClr val="000000"/>
                 </a:solidFill>
                 <a:latin typeface="Calibri"/>
               </a:rPr>
-              <a:t>SHP-DEMO-LOCAL-ZMW / SHP-DEMO-AUTO-FX</a:t>
+              <a:t>dual modes, paperwork costs, CSV, Clear drafts</a:t>
             </a:r>
           </a:p>
           <a:p>
@@ -3700,50 +3719,83 @@
               </a:spcAft>
             </a:pPr>
             <a:r>
-              <a:rPr sz="1800" b="1">
+              <a:rPr sz="1900" b="1">
                 <a:solidFill>
                   <a:srgbClr val="102A38"/>
                 </a:solidFill>
                 <a:latin typeface="Calibri"/>
               </a:rPr>
-              <a:t>•  Security: </a:t>
-            </a:r>
-            <a:r>
-              <a:rPr sz="1800" b="0">
+              <a:t>•  True Cost studio: </a:t>
+            </a:r>
+            <a:r>
+              <a:rPr sz="1900" b="0">
                 <a:solidFill>
                   <a:srgbClr val="000000"/>
                 </a:solidFill>
                 <a:latin typeface="Calibri"/>
               </a:rPr>
-              <a:t>bcrypt · JWT Bearer · Pydantic validation</a:t>
-            </a:r>
-          </a:p>
-        </p:txBody>
-      </p:sp>
-      <p:pic>
-        <p:nvPicPr>
-          <p:cNvPr id="8" name="Picture 7" descr="true_cost_workflow.png"/>
-          <p:cNvPicPr>
-            <a:picLocks noChangeAspect="1"/>
-          </p:cNvPicPr>
-          <p:nvPr/>
-        </p:nvPicPr>
-        <p:blipFill>
-          <a:blip r:embed="rId2"/>
-          <a:stretch>
-            <a:fillRect/>
-          </a:stretch>
-        </p:blipFill>
-        <p:spPr>
-          <a:xfrm>
-            <a:off x="2364848" y="3337560"/>
-            <a:ext cx="7461998" cy="2651760"/>
-          </a:xfrm>
-          <a:prstGeom prst="rect">
-            <a:avLst/>
-          </a:prstGeom>
-        </p:spPr>
-      </p:pic>
+              <a:t>Lines → Allocate → Price → Commit</a:t>
+            </a:r>
+          </a:p>
+          <a:p>
+            <a:pPr>
+              <a:spcAft>
+                <a:spcPts val="1200"/>
+              </a:spcAft>
+            </a:pPr>
+            <a:r>
+              <a:rPr sz="1900" b="1">
+                <a:solidFill>
+                  <a:srgbClr val="102A38"/>
+                </a:solidFill>
+                <a:latin typeface="Calibri"/>
+              </a:rPr>
+              <a:t>•  FX service: </a:t>
+            </a:r>
+            <a:r>
+              <a:rPr sz="1900" b="0">
+                <a:solidFill>
+                  <a:srgbClr val="000000"/>
+                </a:solidFill>
+                <a:latin typeface="Calibri"/>
+              </a:rPr>
+              <a:t>Fetch / cache / starter 20 / manual</a:t>
+            </a:r>
+          </a:p>
+          <a:p>
+            <a:pPr>
+              <a:spcAft>
+                <a:spcPts val="1200"/>
+              </a:spcAft>
+            </a:pPr>
+            <a:r>
+              <a:rPr sz="1900" b="0">
+                <a:solidFill>
+                  <a:srgbClr val="000000"/>
+                </a:solidFill>
+                <a:latin typeface="Calibri"/>
+              </a:rPr>
+              <a:t>•  Stock board + Record sale (stock-out only — not POS)</a:t>
+            </a:r>
+          </a:p>
+          <a:p>
+            <a:pPr>
+              <a:spcAft>
+                <a:spcPts val="1200"/>
+              </a:spcAft>
+            </a:pPr>
+            <a:r>
+              <a:rPr sz="1900" b="0">
+                <a:solidFill>
+                  <a:srgbClr val="000000"/>
+                </a:solidFill>
+                <a:latin typeface="Calibri"/>
+              </a:rPr>
+              <a:t>•  Dashboard Start fresh + Cost history (When / What)</a:t>
+            </a:r>
+          </a:p>
+        </p:txBody>
+      </p:sp>
     </p:spTree>
   </p:cSld>
   <p:clrMapOvr>
@@ -3912,7 +3964,7 @@
                 </a:solidFill>
                 <a:latin typeface="Calibri"/>
               </a:rPr>
-              <a:t>11 / 16</a:t>
+              <a:t>11 / 17</a:t>
             </a:r>
           </a:p>
         </p:txBody>
@@ -3946,7 +3998,7 @@
                 </a:solidFill>
                 <a:latin typeface="Calibri"/>
               </a:rPr>
-              <a:t>Challenges and Solutions</a:t>
+              <a:t>Key Implementation Details</a:t>
             </a:r>
           </a:p>
         </p:txBody>
@@ -3959,8 +4011,8 @@
         </p:nvSpPr>
         <p:spPr>
           <a:xfrm>
-            <a:off x="548640" y="1051560"/>
-            <a:ext cx="10972800" cy="4754880"/>
+            <a:off x="548640" y="1005840"/>
+            <a:ext cx="10972800" cy="2286000"/>
           </a:xfrm>
           <a:prstGeom prst="rect">
             <a:avLst/>
@@ -3979,13 +4031,13 @@
               </a:spcAft>
             </a:pPr>
             <a:r>
-              <a:rPr sz="2000" b="0">
+              <a:rPr sz="1800" b="0">
                 <a:solidFill>
                   <a:srgbClr val="000000"/>
                 </a:solidFill>
                 <a:latin typeface="Calibri"/>
               </a:rPr>
-              <a:t>•  Mixed foreign/local paperwork → Dual cost modes at shipment create</a:t>
+              <a:t>•  React web admin instead of React Native — prioritise desk costing MVP</a:t>
             </a:r>
           </a:p>
           <a:p>
@@ -3995,13 +4047,13 @@
               </a:spcAft>
             </a:pPr>
             <a:r>
-              <a:rPr sz="2000" b="0">
+              <a:rPr sz="1800" b="0">
                 <a:solidFill>
                   <a:srgbClr val="000000"/>
                 </a:solidFill>
                 <a:latin typeface="Calibri"/>
               </a:rPr>
-              <a:t>•  React Native scope risk → Deliver React web admin; defer mobile companion</a:t>
+              <a:t>•  Strategy (modes/allocation) · Facade (commit) · Chain (FX providers)</a:t>
             </a:r>
           </a:p>
           <a:p>
@@ -4011,13 +4063,22 @@
               </a:spcAft>
             </a:pPr>
             <a:r>
-              <a:rPr sz="2000" b="0">
+              <a:rPr sz="1800" b="1">
+                <a:solidFill>
+                  <a:srgbClr val="102A38"/>
+                </a:solidFill>
+                <a:latin typeface="Calibri"/>
+              </a:rPr>
+              <a:t>•  CSV import drives Demo A/B: </a:t>
+            </a:r>
+            <a:r>
+              <a:rPr sz="1800" b="0">
                 <a:solidFill>
                   <a:srgbClr val="000000"/>
                 </a:solidFill>
                 <a:latin typeface="Calibri"/>
               </a:rPr>
-              <a:t>•  FX API downtime → Cache, starter rate 20, manual override</a:t>
+              <a:t>SHP-DEMO-LOCAL-ZMW / SHP-DEMO-AUTO-FX</a:t>
             </a:r>
           </a:p>
           <a:p>
@@ -4027,17 +4088,50 @@
               </a:spcAft>
             </a:pPr>
             <a:r>
-              <a:rPr sz="2000" b="0">
+              <a:rPr sz="1800" b="1">
+                <a:solidFill>
+                  <a:srgbClr val="102A38"/>
+                </a:solidFill>
+                <a:latin typeface="Calibri"/>
+              </a:rPr>
+              <a:t>•  Security: </a:t>
+            </a:r>
+            <a:r>
+              <a:rPr sz="1800" b="0">
                 <a:solidFill>
                   <a:srgbClr val="000000"/>
                 </a:solidFill>
                 <a:latin typeface="Calibri"/>
               </a:rPr>
-              <a:t>•  Opaque spreadsheets → Allocation comparator + Cost history When/What</a:t>
-            </a:r>
-          </a:p>
-        </p:txBody>
-      </p:sp>
+              <a:t>bcrypt · JWT Bearer · Pydantic validation</a:t>
+            </a:r>
+          </a:p>
+        </p:txBody>
+      </p:sp>
+      <p:pic>
+        <p:nvPicPr>
+          <p:cNvPr id="8" name="Picture 7" descr="true_cost_workflow.png"/>
+          <p:cNvPicPr>
+            <a:picLocks noChangeAspect="1"/>
+          </p:cNvPicPr>
+          <p:nvPr/>
+        </p:nvPicPr>
+        <p:blipFill>
+          <a:blip r:embed="rId2"/>
+          <a:stretch>
+            <a:fillRect/>
+          </a:stretch>
+        </p:blipFill>
+        <p:spPr>
+          <a:xfrm>
+            <a:off x="2364848" y="3337560"/>
+            <a:ext cx="7461998" cy="2651760"/>
+          </a:xfrm>
+          <a:prstGeom prst="rect">
+            <a:avLst/>
+          </a:prstGeom>
+        </p:spPr>
+      </p:pic>
     </p:spTree>
   </p:cSld>
   <p:clrMapOvr>
@@ -4206,7 +4300,269 @@
                 </a:solidFill>
                 <a:latin typeface="Calibri"/>
               </a:rPr>
-              <a:t>12 / 16</a:t>
+              <a:t>12 / 17</a:t>
+            </a:r>
+          </a:p>
+        </p:txBody>
+      </p:sp>
+      <p:sp>
+        <p:nvSpPr>
+          <p:cNvPr id="6" name="TextBox 5"/>
+          <p:cNvSpPr txBox="1"/>
+          <p:nvPr/>
+        </p:nvSpPr>
+        <p:spPr>
+          <a:xfrm>
+            <a:off x="457200" y="292608"/>
+            <a:ext cx="11247120" cy="685800"/>
+          </a:xfrm>
+          <a:prstGeom prst="rect">
+            <a:avLst/>
+          </a:prstGeom>
+          <a:noFill/>
+        </p:spPr>
+        <p:txBody>
+          <a:bodyPr wrap="square">
+            <a:spAutoFit/>
+          </a:bodyPr>
+          <a:lstStyle/>
+          <a:p>
+            <a:r>
+              <a:rPr sz="3200" b="1">
+                <a:solidFill>
+                  <a:srgbClr val="102A38"/>
+                </a:solidFill>
+                <a:latin typeface="Calibri"/>
+              </a:rPr>
+              <a:t>Challenges and Solutions</a:t>
+            </a:r>
+          </a:p>
+        </p:txBody>
+      </p:sp>
+      <p:sp>
+        <p:nvSpPr>
+          <p:cNvPr id="7" name="TextBox 6"/>
+          <p:cNvSpPr txBox="1"/>
+          <p:nvPr/>
+        </p:nvSpPr>
+        <p:spPr>
+          <a:xfrm>
+            <a:off x="548640" y="1051560"/>
+            <a:ext cx="10972800" cy="4754880"/>
+          </a:xfrm>
+          <a:prstGeom prst="rect">
+            <a:avLst/>
+          </a:prstGeom>
+          <a:noFill/>
+        </p:spPr>
+        <p:txBody>
+          <a:bodyPr wrap="square">
+            <a:spAutoFit/>
+          </a:bodyPr>
+          <a:lstStyle/>
+          <a:p>
+            <a:pPr>
+              <a:spcAft>
+                <a:spcPts val="1200"/>
+              </a:spcAft>
+            </a:pPr>
+            <a:r>
+              <a:rPr sz="2000" b="0">
+                <a:solidFill>
+                  <a:srgbClr val="000000"/>
+                </a:solidFill>
+                <a:latin typeface="Calibri"/>
+              </a:rPr>
+              <a:t>•  Mixed foreign/local paperwork → Dual cost modes at shipment create</a:t>
+            </a:r>
+          </a:p>
+          <a:p>
+            <a:pPr>
+              <a:spcAft>
+                <a:spcPts val="1200"/>
+              </a:spcAft>
+            </a:pPr>
+            <a:r>
+              <a:rPr sz="2000" b="0">
+                <a:solidFill>
+                  <a:srgbClr val="000000"/>
+                </a:solidFill>
+                <a:latin typeface="Calibri"/>
+              </a:rPr>
+              <a:t>•  FX API downtime → Cache, starter rate 20, manual override</a:t>
+            </a:r>
+          </a:p>
+        </p:txBody>
+      </p:sp>
+    </p:spTree>
+  </p:cSld>
+  <p:clrMapOvr>
+    <a:masterClrMapping/>
+  </p:clrMapOvr>
+</p:sld>
+</file>
+
+<file path=ppt/slides/slide13.xml><?xml version="1.0" encoding="utf-8"?>
+<p:sld xmlns:a="http://schemas.openxmlformats.org/drawingml/2006/main" xmlns:p="http://schemas.openxmlformats.org/presentationml/2006/main" xmlns:r="http://schemas.openxmlformats.org/officeDocument/2006/relationships">
+  <p:cSld>
+    <p:spTree>
+      <p:nvGrpSpPr>
+        <p:cNvPr id="1" name=""/>
+        <p:cNvGrpSpPr/>
+        <p:nvPr/>
+      </p:nvGrpSpPr>
+      <p:grpSpPr/>
+      <p:sp>
+        <p:nvSpPr>
+          <p:cNvPr id="2" name="Rectangle 1"/>
+          <p:cNvSpPr/>
+          <p:nvPr/>
+        </p:nvSpPr>
+        <p:spPr>
+          <a:xfrm>
+            <a:off x="0" y="0"/>
+            <a:ext cx="12191695" cy="146304"/>
+          </a:xfrm>
+          <a:prstGeom prst="rect">
+            <a:avLst/>
+          </a:prstGeom>
+          <a:solidFill>
+            <a:srgbClr val="1F5A68"/>
+          </a:solidFill>
+          <a:ln>
+            <a:noFill/>
+          </a:ln>
+        </p:spPr>
+        <p:style>
+          <a:lnRef idx="1">
+            <a:schemeClr val="accent1"/>
+          </a:lnRef>
+          <a:fillRef idx="3">
+            <a:schemeClr val="accent1"/>
+          </a:fillRef>
+          <a:effectRef idx="2">
+            <a:schemeClr val="accent1"/>
+          </a:effectRef>
+          <a:fontRef idx="minor">
+            <a:schemeClr val="lt1"/>
+          </a:fontRef>
+        </p:style>
+        <p:txBody>
+          <a:bodyPr rtlCol="0" anchor="ctr"/>
+          <a:lstStyle/>
+          <a:p>
+            <a:pPr algn="ctr"/>
+          </a:p>
+        </p:txBody>
+      </p:sp>
+      <p:sp>
+        <p:nvSpPr>
+          <p:cNvPr id="3" name="Rectangle 2"/>
+          <p:cNvSpPr/>
+          <p:nvPr/>
+        </p:nvSpPr>
+        <p:spPr>
+          <a:xfrm>
+            <a:off x="0" y="6419088"/>
+            <a:ext cx="12191695" cy="438912"/>
+          </a:xfrm>
+          <a:prstGeom prst="rect">
+            <a:avLst/>
+          </a:prstGeom>
+          <a:solidFill>
+            <a:srgbClr val="E8EEF1"/>
+          </a:solidFill>
+          <a:ln>
+            <a:noFill/>
+          </a:ln>
+        </p:spPr>
+        <p:style>
+          <a:lnRef idx="1">
+            <a:schemeClr val="accent1"/>
+          </a:lnRef>
+          <a:fillRef idx="3">
+            <a:schemeClr val="accent1"/>
+          </a:fillRef>
+          <a:effectRef idx="2">
+            <a:schemeClr val="accent1"/>
+          </a:effectRef>
+          <a:fontRef idx="minor">
+            <a:schemeClr val="lt1"/>
+          </a:fontRef>
+        </p:style>
+        <p:txBody>
+          <a:bodyPr rtlCol="0" anchor="ctr"/>
+          <a:lstStyle/>
+          <a:p>
+            <a:pPr algn="ctr"/>
+          </a:p>
+        </p:txBody>
+      </p:sp>
+      <p:sp>
+        <p:nvSpPr>
+          <p:cNvPr id="4" name="TextBox 3"/>
+          <p:cNvSpPr txBox="1"/>
+          <p:nvPr/>
+        </p:nvSpPr>
+        <p:spPr>
+          <a:xfrm>
+            <a:off x="365760" y="6473952"/>
+            <a:ext cx="9601200" cy="329184"/>
+          </a:xfrm>
+          <a:prstGeom prst="rect">
+            <a:avLst/>
+          </a:prstGeom>
+          <a:noFill/>
+        </p:spPr>
+        <p:txBody>
+          <a:bodyPr wrap="none">
+            <a:spAutoFit/>
+          </a:bodyPr>
+          <a:lstStyle/>
+          <a:p>
+            <a:r>
+              <a:rPr sz="1300" b="1">
+                <a:solidFill>
+                  <a:srgbClr val="2A353C"/>
+                </a:solidFill>
+                <a:latin typeface="Calibri"/>
+              </a:rPr>
+              <a:t>Tranz-Algo  ·  Final Year Project  ·  Academic Year 2026</a:t>
+            </a:r>
+          </a:p>
+        </p:txBody>
+      </p:sp>
+      <p:sp>
+        <p:nvSpPr>
+          <p:cNvPr id="5" name="TextBox 4"/>
+          <p:cNvSpPr txBox="1"/>
+          <p:nvPr/>
+        </p:nvSpPr>
+        <p:spPr>
+          <a:xfrm>
+            <a:off x="10911535" y="6473952"/>
+            <a:ext cx="1005840" cy="329184"/>
+          </a:xfrm>
+          <a:prstGeom prst="rect">
+            <a:avLst/>
+          </a:prstGeom>
+          <a:noFill/>
+        </p:spPr>
+        <p:txBody>
+          <a:bodyPr wrap="none">
+            <a:spAutoFit/>
+          </a:bodyPr>
+          <a:lstStyle/>
+          <a:p>
+            <a:pPr algn="r"/>
+            <a:r>
+              <a:rPr sz="1300" b="1">
+                <a:solidFill>
+                  <a:srgbClr val="102A38"/>
+                </a:solidFill>
+                <a:latin typeface="Calibri"/>
+              </a:rPr>
+              <a:t>13 / 17</a:t>
             </a:r>
           </a:p>
         </p:txBody>
@@ -4491,7 +4847,7 @@
                           </a:solidFill>
                           <a:latin typeface="Calibri"/>
                         </a:rPr>
-                        <a:t>Auto FX Demo B vs expected costs (check rate 27.50)</a:t>
+                        <a:t>Auto FX Demo B vs expected costs (rate 20)</a:t>
                       </a:r>
                     </a:p>
                   </a:txBody>
@@ -4888,334 +5244,6 @@
 </p:sld>
 </file>
 
-<file path=ppt/slides/slide13.xml><?xml version="1.0" encoding="utf-8"?>
-<p:sld xmlns:a="http://schemas.openxmlformats.org/drawingml/2006/main" xmlns:p="http://schemas.openxmlformats.org/presentationml/2006/main" xmlns:r="http://schemas.openxmlformats.org/officeDocument/2006/relationships">
-  <p:cSld>
-    <p:spTree>
-      <p:nvGrpSpPr>
-        <p:cNvPr id="1" name=""/>
-        <p:cNvGrpSpPr/>
-        <p:nvPr/>
-      </p:nvGrpSpPr>
-      <p:grpSpPr/>
-      <p:sp>
-        <p:nvSpPr>
-          <p:cNvPr id="2" name="Rectangle 1"/>
-          <p:cNvSpPr/>
-          <p:nvPr/>
-        </p:nvSpPr>
-        <p:spPr>
-          <a:xfrm>
-            <a:off x="0" y="0"/>
-            <a:ext cx="12191695" cy="146304"/>
-          </a:xfrm>
-          <a:prstGeom prst="rect">
-            <a:avLst/>
-          </a:prstGeom>
-          <a:solidFill>
-            <a:srgbClr val="1F5A68"/>
-          </a:solidFill>
-          <a:ln>
-            <a:noFill/>
-          </a:ln>
-        </p:spPr>
-        <p:style>
-          <a:lnRef idx="1">
-            <a:schemeClr val="accent1"/>
-          </a:lnRef>
-          <a:fillRef idx="3">
-            <a:schemeClr val="accent1"/>
-          </a:fillRef>
-          <a:effectRef idx="2">
-            <a:schemeClr val="accent1"/>
-          </a:effectRef>
-          <a:fontRef idx="minor">
-            <a:schemeClr val="lt1"/>
-          </a:fontRef>
-        </p:style>
-        <p:txBody>
-          <a:bodyPr rtlCol="0" anchor="ctr"/>
-          <a:lstStyle/>
-          <a:p>
-            <a:pPr algn="ctr"/>
-          </a:p>
-        </p:txBody>
-      </p:sp>
-      <p:sp>
-        <p:nvSpPr>
-          <p:cNvPr id="3" name="Rectangle 2"/>
-          <p:cNvSpPr/>
-          <p:nvPr/>
-        </p:nvSpPr>
-        <p:spPr>
-          <a:xfrm>
-            <a:off x="0" y="6419088"/>
-            <a:ext cx="12191695" cy="438912"/>
-          </a:xfrm>
-          <a:prstGeom prst="rect">
-            <a:avLst/>
-          </a:prstGeom>
-          <a:solidFill>
-            <a:srgbClr val="E8EEF1"/>
-          </a:solidFill>
-          <a:ln>
-            <a:noFill/>
-          </a:ln>
-        </p:spPr>
-        <p:style>
-          <a:lnRef idx="1">
-            <a:schemeClr val="accent1"/>
-          </a:lnRef>
-          <a:fillRef idx="3">
-            <a:schemeClr val="accent1"/>
-          </a:fillRef>
-          <a:effectRef idx="2">
-            <a:schemeClr val="accent1"/>
-          </a:effectRef>
-          <a:fontRef idx="minor">
-            <a:schemeClr val="lt1"/>
-          </a:fontRef>
-        </p:style>
-        <p:txBody>
-          <a:bodyPr rtlCol="0" anchor="ctr"/>
-          <a:lstStyle/>
-          <a:p>
-            <a:pPr algn="ctr"/>
-          </a:p>
-        </p:txBody>
-      </p:sp>
-      <p:sp>
-        <p:nvSpPr>
-          <p:cNvPr id="4" name="TextBox 3"/>
-          <p:cNvSpPr txBox="1"/>
-          <p:nvPr/>
-        </p:nvSpPr>
-        <p:spPr>
-          <a:xfrm>
-            <a:off x="365760" y="6473952"/>
-            <a:ext cx="9601200" cy="329184"/>
-          </a:xfrm>
-          <a:prstGeom prst="rect">
-            <a:avLst/>
-          </a:prstGeom>
-          <a:noFill/>
-        </p:spPr>
-        <p:txBody>
-          <a:bodyPr wrap="none">
-            <a:spAutoFit/>
-          </a:bodyPr>
-          <a:lstStyle/>
-          <a:p>
-            <a:r>
-              <a:rPr sz="1300" b="1">
-                <a:solidFill>
-                  <a:srgbClr val="2A353C"/>
-                </a:solidFill>
-                <a:latin typeface="Calibri"/>
-              </a:rPr>
-              <a:t>Tranz-Algo  ·  Final Year Project  ·  Academic Year 2026</a:t>
-            </a:r>
-          </a:p>
-        </p:txBody>
-      </p:sp>
-      <p:sp>
-        <p:nvSpPr>
-          <p:cNvPr id="5" name="TextBox 4"/>
-          <p:cNvSpPr txBox="1"/>
-          <p:nvPr/>
-        </p:nvSpPr>
-        <p:spPr>
-          <a:xfrm>
-            <a:off x="10911535" y="6473952"/>
-            <a:ext cx="1005840" cy="329184"/>
-          </a:xfrm>
-          <a:prstGeom prst="rect">
-            <a:avLst/>
-          </a:prstGeom>
-          <a:noFill/>
-        </p:spPr>
-        <p:txBody>
-          <a:bodyPr wrap="none">
-            <a:spAutoFit/>
-          </a:bodyPr>
-          <a:lstStyle/>
-          <a:p>
-            <a:pPr algn="r"/>
-            <a:r>
-              <a:rPr sz="1300" b="1">
-                <a:solidFill>
-                  <a:srgbClr val="102A38"/>
-                </a:solidFill>
-                <a:latin typeface="Calibri"/>
-              </a:rPr>
-              <a:t>13 / 16</a:t>
-            </a:r>
-          </a:p>
-        </p:txBody>
-      </p:sp>
-      <p:sp>
-        <p:nvSpPr>
-          <p:cNvPr id="6" name="TextBox 5"/>
-          <p:cNvSpPr txBox="1"/>
-          <p:nvPr/>
-        </p:nvSpPr>
-        <p:spPr>
-          <a:xfrm>
-            <a:off x="457200" y="292608"/>
-            <a:ext cx="11247120" cy="685800"/>
-          </a:xfrm>
-          <a:prstGeom prst="rect">
-            <a:avLst/>
-          </a:prstGeom>
-          <a:noFill/>
-        </p:spPr>
-        <p:txBody>
-          <a:bodyPr wrap="square">
-            <a:spAutoFit/>
-          </a:bodyPr>
-          <a:lstStyle/>
-          <a:p>
-            <a:r>
-              <a:rPr sz="3200" b="1">
-                <a:solidFill>
-                  <a:srgbClr val="102A38"/>
-                </a:solidFill>
-                <a:latin typeface="Calibri"/>
-              </a:rPr>
-              <a:t>Discussion of Findings</a:t>
-            </a:r>
-          </a:p>
-        </p:txBody>
-      </p:sp>
-      <p:sp>
-        <p:nvSpPr>
-          <p:cNvPr id="7" name="TextBox 6"/>
-          <p:cNvSpPr txBox="1"/>
-          <p:nvPr/>
-        </p:nvSpPr>
-        <p:spPr>
-          <a:xfrm>
-            <a:off x="548640" y="1051560"/>
-            <a:ext cx="10972800" cy="4754880"/>
-          </a:xfrm>
-          <a:prstGeom prst="rect">
-            <a:avLst/>
-          </a:prstGeom>
-          <a:noFill/>
-        </p:spPr>
-        <p:txBody>
-          <a:bodyPr wrap="square">
-            <a:spAutoFit/>
-          </a:bodyPr>
-          <a:lstStyle/>
-          <a:p>
-            <a:pPr>
-              <a:spcAft>
-                <a:spcPts val="1200"/>
-              </a:spcAft>
-            </a:pPr>
-            <a:r>
-              <a:rPr sz="2000" b="0">
-                <a:solidFill>
-                  <a:srgbClr val="000000"/>
-                </a:solidFill>
-                <a:latin typeface="Calibri"/>
-              </a:rPr>
-              <a:t>•  Demo A/B costs matched our pre-calculated spreadsheet answers — formulas are correct</a:t>
-            </a:r>
-          </a:p>
-          <a:p>
-            <a:pPr>
-              <a:spcAft>
-                <a:spcPts val="1200"/>
-              </a:spcAft>
-            </a:pPr>
-            <a:r>
-              <a:rPr sz="2000" b="0">
-                <a:solidFill>
-                  <a:srgbClr val="000000"/>
-                </a:solidFill>
-                <a:latin typeface="Calibri"/>
-              </a:rPr>
-              <a:t>•  Dual modes address mixed paperwork — the original problem</a:t>
-            </a:r>
-          </a:p>
-          <a:p>
-            <a:pPr>
-              <a:spcAft>
-                <a:spcPts val="1200"/>
-              </a:spcAft>
-            </a:pPr>
-            <a:r>
-              <a:rPr sz="2000" b="0">
-                <a:solidFill>
-                  <a:srgbClr val="000000"/>
-                </a:solidFill>
-                <a:latin typeface="Calibri"/>
-              </a:rPr>
-              <a:t>•  Design, build and evaluate objectives were met for MVP scope</a:t>
-            </a:r>
-          </a:p>
-          <a:p>
-            <a:pPr>
-              <a:spcAft>
-                <a:spcPts val="1200"/>
-              </a:spcAft>
-            </a:pPr>
-            <a:r>
-              <a:rPr sz="2000" b="1">
-                <a:solidFill>
-                  <a:srgbClr val="102A38"/>
-                </a:solidFill>
-                <a:latin typeface="Calibri"/>
-              </a:rPr>
-              <a:t>•  Vs existing work: </a:t>
-            </a:r>
-            <a:r>
-              <a:rPr sz="2000" b="0">
-                <a:solidFill>
-                  <a:srgbClr val="000000"/>
-                </a:solidFill>
-                <a:latin typeface="Calibri"/>
-              </a:rPr>
-              <a:t>narrower than ERP, clearer than spreadsheets, not a POS</a:t>
-            </a:r>
-          </a:p>
-          <a:p>
-            <a:pPr>
-              <a:spcAft>
-                <a:spcPts val="1200"/>
-              </a:spcAft>
-            </a:pPr>
-            <a:r>
-              <a:rPr sz="2000" b="1">
-                <a:solidFill>
-                  <a:srgbClr val="102A38"/>
-                </a:solidFill>
-                <a:latin typeface="Calibri"/>
-              </a:rPr>
-              <a:t>•  Key finding: </a:t>
-            </a:r>
-            <a:r>
-              <a:rPr sz="2000" b="0">
-                <a:solidFill>
-                  <a:srgbClr val="000000"/>
-                </a:solidFill>
-                <a:latin typeface="Calibri"/>
-              </a:rPr>
-              <a:t>explainable batch costing can be accurate and usable</a:t>
-            </a:r>
-          </a:p>
-        </p:txBody>
-      </p:sp>
-    </p:spTree>
-  </p:cSld>
-  <p:clrMapOvr>
-    <a:masterClrMapping/>
-  </p:clrMapOvr>
-</p:sld>
-</file>
-
 <file path=ppt/slides/slide14.xml><?xml version="1.0" encoding="utf-8"?>
 <p:sld xmlns:a="http://schemas.openxmlformats.org/drawingml/2006/main" xmlns:p="http://schemas.openxmlformats.org/presentationml/2006/main" xmlns:r="http://schemas.openxmlformats.org/officeDocument/2006/relationships">
   <p:cSld>
@@ -5376,7 +5404,7 @@
                 </a:solidFill>
                 <a:latin typeface="Calibri"/>
               </a:rPr>
-              <a:t>14 / 16</a:t>
+              <a:t>14 / 17</a:t>
             </a:r>
           </a:p>
         </p:txBody>
@@ -5410,7 +5438,7 @@
                 </a:solidFill>
                 <a:latin typeface="Calibri"/>
               </a:rPr>
-              <a:t>Limitations</a:t>
+              <a:t>Discussion of Findings</a:t>
             </a:r>
           </a:p>
         </p:txBody>
@@ -5449,7 +5477,7 @@
                 </a:solidFill>
                 <a:latin typeface="Calibri"/>
               </a:rPr>
-              <a:t>•  Does not legally assess customs duty/VAT — paperwork totals only</a:t>
+              <a:t>•  Demo A/B costs matched our pre-calculated spreadsheet answers — formulas are correct</a:t>
             </a:r>
           </a:p>
           <a:p>
@@ -5465,7 +5493,7 @@
                 </a:solidFill>
                 <a:latin typeface="Calibri"/>
               </a:rPr>
-              <a:t>•  UI Auto FX starts at 20 (or last cache); Demo B number-check uses rate 27.50</a:t>
+              <a:t>•  Dual modes address mixed paperwork — the original problem</a:t>
             </a:r>
           </a:p>
           <a:p>
@@ -5481,7 +5509,7 @@
                 </a:solidFill>
                 <a:latin typeface="Calibri"/>
               </a:rPr>
-              <a:t>•  Value-based allocation is stretch in the UI</a:t>
+              <a:t>•  Design, build and evaluate objectives were met for MVP scope</a:t>
             </a:r>
           </a:p>
           <a:p>
@@ -5491,13 +5519,22 @@
               </a:spcAft>
             </a:pPr>
             <a:r>
+              <a:rPr sz="2000" b="1">
+                <a:solidFill>
+                  <a:srgbClr val="102A38"/>
+                </a:solidFill>
+                <a:latin typeface="Calibri"/>
+              </a:rPr>
+              <a:t>•  Key finding: </a:t>
+            </a:r>
+            <a:r>
               <a:rPr sz="2000" b="0">
                 <a:solidFill>
                   <a:srgbClr val="000000"/>
                 </a:solidFill>
                 <a:latin typeface="Calibri"/>
               </a:rPr>
-              <a:t>•  No large-scale SME field trial yet — evaluation is spreadsheet checks + live demo</a:t>
+              <a:t>explainable batch costing can be accurate and usable</a:t>
             </a:r>
           </a:p>
         </p:txBody>
@@ -5670,7 +5707,7 @@
                 </a:solidFill>
                 <a:latin typeface="Calibri"/>
               </a:rPr>
-              <a:t>15 / 16</a:t>
+              <a:t>15 / 17</a:t>
             </a:r>
           </a:p>
         </p:txBody>
@@ -5704,7 +5741,7 @@
                 </a:solidFill>
                 <a:latin typeface="Calibri"/>
               </a:rPr>
-              <a:t>Conclusion</a:t>
+              <a:t>Limitations</a:t>
             </a:r>
           </a:p>
         </p:txBody>
@@ -5743,7 +5780,7 @@
                 </a:solidFill>
                 <a:latin typeface="Calibri"/>
               </a:rPr>
-              <a:t>•  Tranz-Algo delivers explainable import true cost, suggested retail, Cost history and stock</a:t>
+              <a:t>•  Does not legally assess customs duty/VAT — paperwork totals only</a:t>
             </a:r>
           </a:p>
           <a:p>
@@ -5759,7 +5796,7 @@
                 </a:solidFill>
                 <a:latin typeface="Calibri"/>
               </a:rPr>
-              <a:t>•  Design was joint; implementation mostly Nixon with Musonda’s UI / True Cost contribution</a:t>
+              <a:t>•  Auto FX / Demo B number-check use rate 20 (same as UI starter)</a:t>
             </a:r>
           </a:p>
           <a:p>
@@ -5769,22 +5806,13 @@
               </a:spcAft>
             </a:pPr>
             <a:r>
-              <a:rPr sz="2000" b="1">
-                <a:solidFill>
-                  <a:srgbClr val="102A38"/>
-                </a:solidFill>
-                <a:latin typeface="Calibri"/>
-              </a:rPr>
-              <a:t>•  Next: </a:t>
-            </a:r>
-            <a:r>
               <a:rPr sz="2000" b="0">
                 <a:solidFill>
                   <a:srgbClr val="000000"/>
                 </a:solidFill>
                 <a:latin typeface="Calibri"/>
               </a:rPr>
-              <a:t>optional mobile companion, cloud Postgres, usability study</a:t>
+              <a:t>•  Value-based allocation is stretch in the UI</a:t>
             </a:r>
           </a:p>
           <a:p>
@@ -5800,7 +5828,7 @@
                 </a:solidFill>
                 <a:latin typeface="Calibri"/>
               </a:rPr>
-              <a:t>•  Thank you — demonstration follows</a:t>
+              <a:t>•  No large-scale SME field trial yet — evaluation is spreadsheet checks + live demo</a:t>
             </a:r>
           </a:p>
         </p:txBody>
@@ -5832,6 +5860,309 @@
         <p:spPr>
           <a:xfrm>
             <a:off x="0" y="0"/>
+            <a:ext cx="12191695" cy="146304"/>
+          </a:xfrm>
+          <a:prstGeom prst="rect">
+            <a:avLst/>
+          </a:prstGeom>
+          <a:solidFill>
+            <a:srgbClr val="1F5A68"/>
+          </a:solidFill>
+          <a:ln>
+            <a:noFill/>
+          </a:ln>
+        </p:spPr>
+        <p:style>
+          <a:lnRef idx="1">
+            <a:schemeClr val="accent1"/>
+          </a:lnRef>
+          <a:fillRef idx="3">
+            <a:schemeClr val="accent1"/>
+          </a:fillRef>
+          <a:effectRef idx="2">
+            <a:schemeClr val="accent1"/>
+          </a:effectRef>
+          <a:fontRef idx="minor">
+            <a:schemeClr val="lt1"/>
+          </a:fontRef>
+        </p:style>
+        <p:txBody>
+          <a:bodyPr rtlCol="0" anchor="ctr"/>
+          <a:lstStyle/>
+          <a:p>
+            <a:pPr algn="ctr"/>
+          </a:p>
+        </p:txBody>
+      </p:sp>
+      <p:sp>
+        <p:nvSpPr>
+          <p:cNvPr id="3" name="Rectangle 2"/>
+          <p:cNvSpPr/>
+          <p:nvPr/>
+        </p:nvSpPr>
+        <p:spPr>
+          <a:xfrm>
+            <a:off x="0" y="6419088"/>
+            <a:ext cx="12191695" cy="438912"/>
+          </a:xfrm>
+          <a:prstGeom prst="rect">
+            <a:avLst/>
+          </a:prstGeom>
+          <a:solidFill>
+            <a:srgbClr val="E8EEF1"/>
+          </a:solidFill>
+          <a:ln>
+            <a:noFill/>
+          </a:ln>
+        </p:spPr>
+        <p:style>
+          <a:lnRef idx="1">
+            <a:schemeClr val="accent1"/>
+          </a:lnRef>
+          <a:fillRef idx="3">
+            <a:schemeClr val="accent1"/>
+          </a:fillRef>
+          <a:effectRef idx="2">
+            <a:schemeClr val="accent1"/>
+          </a:effectRef>
+          <a:fontRef idx="minor">
+            <a:schemeClr val="lt1"/>
+          </a:fontRef>
+        </p:style>
+        <p:txBody>
+          <a:bodyPr rtlCol="0" anchor="ctr"/>
+          <a:lstStyle/>
+          <a:p>
+            <a:pPr algn="ctr"/>
+          </a:p>
+        </p:txBody>
+      </p:sp>
+      <p:sp>
+        <p:nvSpPr>
+          <p:cNvPr id="4" name="TextBox 3"/>
+          <p:cNvSpPr txBox="1"/>
+          <p:nvPr/>
+        </p:nvSpPr>
+        <p:spPr>
+          <a:xfrm>
+            <a:off x="365760" y="6473952"/>
+            <a:ext cx="9601200" cy="329184"/>
+          </a:xfrm>
+          <a:prstGeom prst="rect">
+            <a:avLst/>
+          </a:prstGeom>
+          <a:noFill/>
+        </p:spPr>
+        <p:txBody>
+          <a:bodyPr wrap="none">
+            <a:spAutoFit/>
+          </a:bodyPr>
+          <a:lstStyle/>
+          <a:p>
+            <a:r>
+              <a:rPr sz="1300" b="1">
+                <a:solidFill>
+                  <a:srgbClr val="2A353C"/>
+                </a:solidFill>
+                <a:latin typeface="Calibri"/>
+              </a:rPr>
+              <a:t>Tranz-Algo  ·  Final Year Project  ·  Academic Year 2026</a:t>
+            </a:r>
+          </a:p>
+        </p:txBody>
+      </p:sp>
+      <p:sp>
+        <p:nvSpPr>
+          <p:cNvPr id="5" name="TextBox 4"/>
+          <p:cNvSpPr txBox="1"/>
+          <p:nvPr/>
+        </p:nvSpPr>
+        <p:spPr>
+          <a:xfrm>
+            <a:off x="10911535" y="6473952"/>
+            <a:ext cx="1005840" cy="329184"/>
+          </a:xfrm>
+          <a:prstGeom prst="rect">
+            <a:avLst/>
+          </a:prstGeom>
+          <a:noFill/>
+        </p:spPr>
+        <p:txBody>
+          <a:bodyPr wrap="none">
+            <a:spAutoFit/>
+          </a:bodyPr>
+          <a:lstStyle/>
+          <a:p>
+            <a:pPr algn="r"/>
+            <a:r>
+              <a:rPr sz="1300" b="1">
+                <a:solidFill>
+                  <a:srgbClr val="102A38"/>
+                </a:solidFill>
+                <a:latin typeface="Calibri"/>
+              </a:rPr>
+              <a:t>16 / 17</a:t>
+            </a:r>
+          </a:p>
+        </p:txBody>
+      </p:sp>
+      <p:sp>
+        <p:nvSpPr>
+          <p:cNvPr id="6" name="TextBox 5"/>
+          <p:cNvSpPr txBox="1"/>
+          <p:nvPr/>
+        </p:nvSpPr>
+        <p:spPr>
+          <a:xfrm>
+            <a:off x="457200" y="292608"/>
+            <a:ext cx="11247120" cy="685800"/>
+          </a:xfrm>
+          <a:prstGeom prst="rect">
+            <a:avLst/>
+          </a:prstGeom>
+          <a:noFill/>
+        </p:spPr>
+        <p:txBody>
+          <a:bodyPr wrap="square">
+            <a:spAutoFit/>
+          </a:bodyPr>
+          <a:lstStyle/>
+          <a:p>
+            <a:r>
+              <a:rPr sz="3200" b="1">
+                <a:solidFill>
+                  <a:srgbClr val="102A38"/>
+                </a:solidFill>
+                <a:latin typeface="Calibri"/>
+              </a:rPr>
+              <a:t>Conclusion</a:t>
+            </a:r>
+          </a:p>
+        </p:txBody>
+      </p:sp>
+      <p:sp>
+        <p:nvSpPr>
+          <p:cNvPr id="7" name="TextBox 6"/>
+          <p:cNvSpPr txBox="1"/>
+          <p:nvPr/>
+        </p:nvSpPr>
+        <p:spPr>
+          <a:xfrm>
+            <a:off x="548640" y="1051560"/>
+            <a:ext cx="10972800" cy="4754880"/>
+          </a:xfrm>
+          <a:prstGeom prst="rect">
+            <a:avLst/>
+          </a:prstGeom>
+          <a:noFill/>
+        </p:spPr>
+        <p:txBody>
+          <a:bodyPr wrap="square">
+            <a:spAutoFit/>
+          </a:bodyPr>
+          <a:lstStyle/>
+          <a:p>
+            <a:pPr>
+              <a:spcAft>
+                <a:spcPts val="1200"/>
+              </a:spcAft>
+            </a:pPr>
+            <a:r>
+              <a:rPr sz="2000" b="0">
+                <a:solidFill>
+                  <a:srgbClr val="000000"/>
+                </a:solidFill>
+                <a:latin typeface="Calibri"/>
+              </a:rPr>
+              <a:t>•  Tranz-Algo delivers explainable import true cost, suggested retail, Cost history and stock</a:t>
+            </a:r>
+          </a:p>
+          <a:p>
+            <a:pPr>
+              <a:spcAft>
+                <a:spcPts val="1200"/>
+              </a:spcAft>
+            </a:pPr>
+            <a:r>
+              <a:rPr sz="2000" b="0">
+                <a:solidFill>
+                  <a:srgbClr val="000000"/>
+                </a:solidFill>
+                <a:latin typeface="Calibri"/>
+              </a:rPr>
+              <a:t>•  Design was joint; implementation mostly Nixon with Musonda’s UI / True Cost contribution</a:t>
+            </a:r>
+          </a:p>
+          <a:p>
+            <a:pPr>
+              <a:spcAft>
+                <a:spcPts val="1200"/>
+              </a:spcAft>
+            </a:pPr>
+            <a:r>
+              <a:rPr sz="2000" b="1">
+                <a:solidFill>
+                  <a:srgbClr val="102A38"/>
+                </a:solidFill>
+                <a:latin typeface="Calibri"/>
+              </a:rPr>
+              <a:t>•  Next: </a:t>
+            </a:r>
+            <a:r>
+              <a:rPr sz="2000" b="0">
+                <a:solidFill>
+                  <a:srgbClr val="000000"/>
+                </a:solidFill>
+                <a:latin typeface="Calibri"/>
+              </a:rPr>
+              <a:t>optional mobile companion, cloud Postgres, usability study</a:t>
+            </a:r>
+          </a:p>
+          <a:p>
+            <a:pPr>
+              <a:spcAft>
+                <a:spcPts val="1200"/>
+              </a:spcAft>
+            </a:pPr>
+            <a:r>
+              <a:rPr sz="2000" b="0">
+                <a:solidFill>
+                  <a:srgbClr val="000000"/>
+                </a:solidFill>
+                <a:latin typeface="Calibri"/>
+              </a:rPr>
+              <a:t>•  Thank you — demonstration follows</a:t>
+            </a:r>
+          </a:p>
+        </p:txBody>
+      </p:sp>
+    </p:spTree>
+  </p:cSld>
+  <p:clrMapOvr>
+    <a:masterClrMapping/>
+  </p:clrMapOvr>
+</p:sld>
+</file>
+
+<file path=ppt/slides/slide17.xml><?xml version="1.0" encoding="utf-8"?>
+<p:sld xmlns:a="http://schemas.openxmlformats.org/drawingml/2006/main" xmlns:p="http://schemas.openxmlformats.org/presentationml/2006/main" xmlns:r="http://schemas.openxmlformats.org/officeDocument/2006/relationships">
+  <p:cSld>
+    <p:spTree>
+      <p:nvGrpSpPr>
+        <p:cNvPr id="1" name=""/>
+        <p:cNvGrpSpPr/>
+        <p:nvPr/>
+      </p:nvGrpSpPr>
+      <p:grpSpPr/>
+      <p:sp>
+        <p:nvSpPr>
+          <p:cNvPr id="2" name="Rectangle 1"/>
+          <p:cNvSpPr/>
+          <p:nvPr/>
+        </p:nvSpPr>
+        <p:spPr>
+          <a:xfrm>
+            <a:off x="0" y="0"/>
             <a:ext cx="12191695" cy="6858000"/>
           </a:xfrm>
           <a:prstGeom prst="rect">
@@ -6179,7 +6510,7 @@
                 </a:solidFill>
                 <a:latin typeface="Calibri"/>
               </a:rPr>
-              <a:t>2 / 16</a:t>
+              <a:t>2 / 17</a:t>
             </a:r>
           </a:p>
         </p:txBody>
@@ -6538,7 +6869,7 @@
                 </a:solidFill>
                 <a:latin typeface="Calibri"/>
               </a:rPr>
-              <a:t>Supervisor: [SUPERVISOR NAME]</a:t>
+              <a:t>Supervisor: Mrs. Leena Kumar</a:t>
             </a:r>
           </a:p>
         </p:txBody>
@@ -6809,7 +7140,7 @@
                 </a:solidFill>
                 <a:latin typeface="Calibri"/>
               </a:rPr>
-              <a:t>3 / 16</a:t>
+              <a:t>3 / 17</a:t>
             </a:r>
           </a:p>
         </p:txBody>
@@ -6843,7 +7174,7 @@
                 </a:solidFill>
                 <a:latin typeface="Calibri"/>
               </a:rPr>
-              <a:t>Presentation Overview</a:t>
+              <a:t>What is Tranz-Algo?</a:t>
             </a:r>
           </a:p>
         </p:txBody>
@@ -6876,13 +7207,13 @@
               </a:spcAft>
             </a:pPr>
             <a:r>
-              <a:rPr sz="2200" b="0">
+              <a:rPr sz="1900" b="0">
                 <a:solidFill>
                   <a:srgbClr val="000000"/>
                 </a:solidFill>
                 <a:latin typeface="Calibri"/>
               </a:rPr>
-              <a:t>•  Background and Context</a:t>
+              <a:t>•  A web admin app for import retailers — not a till/POS, not customs software, not a full ERP</a:t>
             </a:r>
           </a:p>
           <a:p>
@@ -6892,13 +7223,13 @@
               </a:spcAft>
             </a:pPr>
             <a:r>
-              <a:rPr sz="2200" b="0">
+              <a:rPr sz="1900" b="0">
                 <a:solidFill>
                   <a:srgbClr val="000000"/>
                 </a:solidFill>
                 <a:latin typeface="Calibri"/>
               </a:rPr>
-              <a:t>•  System Analysis and Design (architecture, data, algorithms)</a:t>
+              <a:t>•  You create a shipment batch from supplier invoices plus shipping, duty and VAT paperwork</a:t>
             </a:r>
           </a:p>
           <a:p>
@@ -6908,13 +7239,13 @@
               </a:spcAft>
             </a:pPr>
             <a:r>
-              <a:rPr sz="2200" b="0">
+              <a:rPr sz="1900" b="0">
                 <a:solidFill>
                   <a:srgbClr val="000000"/>
                 </a:solidFill>
                 <a:latin typeface="Calibri"/>
               </a:rPr>
-              <a:t>•  Implementation / Development</a:t>
+              <a:t>•  It splits those shared costs onto each product → a clear true landed cost per unit</a:t>
             </a:r>
           </a:p>
           <a:p>
@@ -6924,13 +7255,13 @@
               </a:spcAft>
             </a:pPr>
             <a:r>
-              <a:rPr sz="2200" b="0">
+              <a:rPr sz="1900" b="0">
                 <a:solidFill>
                   <a:srgbClr val="000000"/>
                 </a:solidFill>
                 <a:latin typeface="Calibri"/>
               </a:rPr>
-              <a:t>•  Testing, Results and Evaluation</a:t>
+              <a:t>•  It suggests a safe retail price (your margin, with a 10% safety floor above landed cost)</a:t>
             </a:r>
           </a:p>
           <a:p>
@@ -6940,13 +7271,22 @@
               </a:spcAft>
             </a:pPr>
             <a:r>
-              <a:rPr sz="2200" b="0">
+              <a:rPr sz="1900" b="1">
+                <a:solidFill>
+                  <a:srgbClr val="102A38"/>
+                </a:solidFill>
+                <a:latin typeface="Calibri"/>
+              </a:rPr>
+              <a:t>•  When you commit: </a:t>
+            </a:r>
+            <a:r>
+              <a:rPr sz="1900" b="0">
                 <a:solidFill>
                   <a:srgbClr val="000000"/>
                 </a:solidFill>
                 <a:latin typeface="Calibri"/>
               </a:rPr>
-              <a:t>•  Discussion</a:t>
+              <a:t>Cost history is saved and shelf stock is updated for that batch</a:t>
             </a:r>
           </a:p>
           <a:p>
@@ -6956,29 +7296,22 @@
               </a:spcAft>
             </a:pPr>
             <a:r>
-              <a:rPr sz="2200" b="0">
+              <a:rPr sz="1900" b="1">
+                <a:solidFill>
+                  <a:srgbClr val="102A38"/>
+                </a:solidFill>
+                <a:latin typeface="Calibri"/>
+              </a:rPr>
+              <a:t>•  Two modes: </a:t>
+            </a:r>
+            <a:r>
+              <a:rPr sz="1900" b="0">
                 <a:solidFill>
                   <a:srgbClr val="000000"/>
                 </a:solidFill>
                 <a:latin typeface="Calibri"/>
               </a:rPr>
-              <a:t>•  Conclusion</a:t>
-            </a:r>
-          </a:p>
-          <a:p>
-            <a:pPr>
-              <a:spcAft>
-                <a:spcPts val="1200"/>
-              </a:spcAft>
-            </a:pPr>
-            <a:r>
-              <a:rPr sz="2200" b="0">
-                <a:solidFill>
-                  <a:srgbClr val="000000"/>
-                </a:solidFill>
-                <a:latin typeface="Calibri"/>
-              </a:rPr>
-              <a:t>•  System Demonstration</a:t>
+              <a:t>Already-Local (amounts already in ZMW) or Auto FX (foreign prices × exchange rate)</a:t>
             </a:r>
           </a:p>
         </p:txBody>
@@ -7151,7 +7484,7 @@
                 </a:solidFill>
                 <a:latin typeface="Calibri"/>
               </a:rPr>
-              <a:t>4 / 16</a:t>
+              <a:t>4 / 17</a:t>
             </a:r>
           </a:p>
         </p:txBody>
@@ -7185,7 +7518,7 @@
                 </a:solidFill>
                 <a:latin typeface="Calibri"/>
               </a:rPr>
-              <a:t>Background and Context</a:t>
+              <a:t>Presentation Overview</a:t>
             </a:r>
           </a:p>
         </p:txBody>
@@ -7224,7 +7557,7 @@
                 </a:solidFill>
                 <a:latin typeface="Calibri"/>
               </a:rPr>
-              <a:t>•  Import SMEs know invoices and clearing papers, yet struggle to recover per-item true cost</a:t>
+              <a:t>•  What Tranz-Algo is (and is not)</a:t>
             </a:r>
           </a:p>
           <a:p>
@@ -7240,7 +7573,7 @@
                 </a:solidFill>
                 <a:latin typeface="Calibri"/>
               </a:rPr>
-              <a:t>•  Shared freight, duty and VAT plus mixed foreign/local paperwork erase margins</a:t>
+              <a:t>•  Background and Context</a:t>
             </a:r>
           </a:p>
           <a:p>
@@ -7256,7 +7589,7 @@
                 </a:solidFill>
                 <a:latin typeface="Calibri"/>
               </a:rPr>
-              <a:t>•  FX movement can wipe cost-plus pricing after a selling price is set</a:t>
+              <a:t>•  System Analysis and Design (architecture, data, algorithms)</a:t>
             </a:r>
           </a:p>
           <a:p>
@@ -7266,22 +7599,13 @@
               </a:spcAft>
             </a:pPr>
             <a:r>
-              <a:rPr sz="2000" b="1">
-                <a:solidFill>
-                  <a:srgbClr val="102A38"/>
-                </a:solidFill>
-                <a:latin typeface="Calibri"/>
-              </a:rPr>
-              <a:t>•  Users: </a:t>
-            </a:r>
-            <a:r>
               <a:rPr sz="2000" b="0">
                 <a:solidFill>
                   <a:srgbClr val="000000"/>
                 </a:solidFill>
                 <a:latin typeface="Calibri"/>
               </a:rPr>
-              <a:t>retail administrators (desk workflow) — not till operators</a:t>
+              <a:t>•  Implementation / Development</a:t>
             </a:r>
           </a:p>
           <a:p>
@@ -7291,22 +7615,61 @@
               </a:spcAft>
             </a:pPr>
             <a:r>
-              <a:rPr sz="2000" b="1">
-                <a:solidFill>
-                  <a:srgbClr val="102A38"/>
-                </a:solidFill>
-                <a:latin typeface="Calibri"/>
-              </a:rPr>
-              <a:t>•  Tranz-Algo: </a:t>
-            </a:r>
-            <a:r>
               <a:rPr sz="2000" b="0">
                 <a:solidFill>
                   <a:srgbClr val="000000"/>
                 </a:solidFill>
                 <a:latin typeface="Calibri"/>
               </a:rPr>
-              <a:t>landed cost → suggested retail → Cost history → batch stock</a:t>
+              <a:t>•  Testing, Results and Evaluation</a:t>
+            </a:r>
+          </a:p>
+          <a:p>
+            <a:pPr>
+              <a:spcAft>
+                <a:spcPts val="1200"/>
+              </a:spcAft>
+            </a:pPr>
+            <a:r>
+              <a:rPr sz="2000" b="0">
+                <a:solidFill>
+                  <a:srgbClr val="000000"/>
+                </a:solidFill>
+                <a:latin typeface="Calibri"/>
+              </a:rPr>
+              <a:t>•  Discussion</a:t>
+            </a:r>
+          </a:p>
+          <a:p>
+            <a:pPr>
+              <a:spcAft>
+                <a:spcPts val="1200"/>
+              </a:spcAft>
+            </a:pPr>
+            <a:r>
+              <a:rPr sz="2000" b="0">
+                <a:solidFill>
+                  <a:srgbClr val="000000"/>
+                </a:solidFill>
+                <a:latin typeface="Calibri"/>
+              </a:rPr>
+              <a:t>•  Conclusion</a:t>
+            </a:r>
+          </a:p>
+          <a:p>
+            <a:pPr>
+              <a:spcAft>
+                <a:spcPts val="1200"/>
+              </a:spcAft>
+            </a:pPr>
+            <a:r>
+              <a:rPr sz="2000" b="0">
+                <a:solidFill>
+                  <a:srgbClr val="000000"/>
+                </a:solidFill>
+                <a:latin typeface="Calibri"/>
+              </a:rPr>
+              <a:t>•  System Demonstration</a:t>
             </a:r>
           </a:p>
         </p:txBody>
@@ -7479,7 +7842,7 @@
                 </a:solidFill>
                 <a:latin typeface="Calibri"/>
               </a:rPr>
-              <a:t>5 / 16</a:t>
+              <a:t>5 / 17</a:t>
             </a:r>
           </a:p>
         </p:txBody>
@@ -7513,7 +7876,7 @@
                 </a:solidFill>
                 <a:latin typeface="Calibri"/>
               </a:rPr>
-              <a:t>System Architecture</a:t>
+              <a:t>Background and Context</a:t>
             </a:r>
           </a:p>
         </p:txBody>
@@ -7526,8 +7889,8 @@
         </p:nvSpPr>
         <p:spPr>
           <a:xfrm>
-            <a:off x="457200" y="960120"/>
-            <a:ext cx="11247120" cy="411480"/>
+            <a:off x="548640" y="1051560"/>
+            <a:ext cx="10972800" cy="4754880"/>
           </a:xfrm>
           <a:prstGeom prst="rect">
             <a:avLst/>
@@ -7540,42 +7903,105 @@
           </a:bodyPr>
           <a:lstStyle/>
           <a:p>
-            <a:r>
-              <a:rPr sz="1600" b="1">
-                <a:solidFill>
-                  <a:srgbClr val="2A353C"/>
-                </a:solidFill>
-                <a:latin typeface="Calibri"/>
-              </a:rPr>
-              <a:t>Three-tier: React SPA → FastAPI /api/v1 → PostgreSQL (SQLite fallback) · optional Frankfurter FX · JWT</a:t>
-            </a:r>
-          </a:p>
-        </p:txBody>
-      </p:sp>
-      <p:pic>
-        <p:nvPicPr>
-          <p:cNvPr id="8" name="Picture 7" descr="architecture.png"/>
-          <p:cNvPicPr>
-            <a:picLocks noChangeAspect="1"/>
-          </p:cNvPicPr>
-          <p:nvPr/>
-        </p:nvPicPr>
-        <p:blipFill>
-          <a:blip r:embed="rId2"/>
-          <a:stretch>
-            <a:fillRect/>
-          </a:stretch>
-        </p:blipFill>
-        <p:spPr>
-          <a:xfrm>
-            <a:off x="2271867" y="1417320"/>
-            <a:ext cx="7647959" cy="4709160"/>
-          </a:xfrm>
-          <a:prstGeom prst="rect">
-            <a:avLst/>
-          </a:prstGeom>
-        </p:spPr>
-      </p:pic>
+            <a:pPr>
+              <a:spcAft>
+                <a:spcPts val="1200"/>
+              </a:spcAft>
+            </a:pPr>
+            <a:r>
+              <a:rPr sz="2000" b="0">
+                <a:solidFill>
+                  <a:srgbClr val="000000"/>
+                </a:solidFill>
+                <a:latin typeface="Calibri"/>
+              </a:rPr>
+              <a:t>•  Import SMEs know invoices and clearing papers, yet struggle to recover per-item true cost</a:t>
+            </a:r>
+          </a:p>
+          <a:p>
+            <a:pPr>
+              <a:spcAft>
+                <a:spcPts val="1200"/>
+              </a:spcAft>
+            </a:pPr>
+            <a:r>
+              <a:rPr sz="2000" b="0">
+                <a:solidFill>
+                  <a:srgbClr val="000000"/>
+                </a:solidFill>
+                <a:latin typeface="Calibri"/>
+              </a:rPr>
+              <a:t>•  Shared freight, duty and VAT plus mixed foreign/local paperwork erase margins</a:t>
+            </a:r>
+          </a:p>
+          <a:p>
+            <a:pPr>
+              <a:spcAft>
+                <a:spcPts val="1200"/>
+              </a:spcAft>
+            </a:pPr>
+            <a:r>
+              <a:rPr sz="2000" b="0">
+                <a:solidFill>
+                  <a:srgbClr val="000000"/>
+                </a:solidFill>
+                <a:latin typeface="Calibri"/>
+              </a:rPr>
+              <a:t>•  FX movement can wipe cost-plus pricing after a selling price is set</a:t>
+            </a:r>
+          </a:p>
+          <a:p>
+            <a:pPr>
+              <a:spcAft>
+                <a:spcPts val="1200"/>
+              </a:spcAft>
+            </a:pPr>
+            <a:r>
+              <a:rPr sz="2000" b="1">
+                <a:solidFill>
+                  <a:srgbClr val="102A38"/>
+                </a:solidFill>
+                <a:latin typeface="Calibri"/>
+              </a:rPr>
+              <a:t>•  Users: </a:t>
+            </a:r>
+            <a:r>
+              <a:rPr sz="2000" b="0">
+                <a:solidFill>
+                  <a:srgbClr val="000000"/>
+                </a:solidFill>
+                <a:latin typeface="Calibri"/>
+              </a:rPr>
+              <a:t>retail administrators (desk workflow) — not till operators</a:t>
+            </a:r>
+          </a:p>
+          <a:p>
+            <a:pPr>
+              <a:spcAft>
+                <a:spcPts val="1200"/>
+              </a:spcAft>
+            </a:pPr>
+            <a:r>
+              <a:rPr sz="2000" b="1">
+                <a:solidFill>
+                  <a:srgbClr val="102A38"/>
+                </a:solidFill>
+                <a:latin typeface="Calibri"/>
+              </a:rPr>
+              <a:t>•  Tranz-Algo: </a:t>
+            </a:r>
+            <a:r>
+              <a:rPr sz="2000" b="0">
+                <a:solidFill>
+                  <a:srgbClr val="000000"/>
+                </a:solidFill>
+                <a:latin typeface="Calibri"/>
+              </a:rPr>
+              <a:t>landed cost → suggested retail → Cost history → batch stock</a:t>
+            </a:r>
+          </a:p>
+        </p:txBody>
+      </p:sp>
     </p:spTree>
   </p:cSld>
   <p:clrMapOvr>
@@ -7744,7 +8170,7 @@
                 </a:solidFill>
                 <a:latin typeface="Calibri"/>
               </a:rPr>
-              <a:t>6 / 16</a:t>
+              <a:t>6 / 17</a:t>
             </a:r>
           </a:p>
         </p:txBody>
@@ -7778,7 +8204,7 @@
                 </a:solidFill>
                 <a:latin typeface="Calibri"/>
               </a:rPr>
-              <a:t>Database / Data Design</a:t>
+              <a:t>System Architecture</a:t>
             </a:r>
           </a:p>
         </p:txBody>
@@ -7812,14 +8238,14 @@
                 </a:solidFill>
                 <a:latin typeface="Calibri"/>
               </a:rPr>
-              <a:t>UML-style entities · duty/VAT as paperwork totals on the batch · Cost history from ledger · Sale = stock-out only</a:t>
+              <a:t>React screens → FastAPI → services (costing / workflow / FX) → PostgreSQL · optional live FX · JWT</a:t>
             </a:r>
           </a:p>
         </p:txBody>
       </p:sp>
       <p:pic>
         <p:nvPicPr>
-          <p:cNvPr id="8" name="Picture 7" descr="erd.png"/>
+          <p:cNvPr id="8" name="Picture 7" descr="architecture.png"/>
           <p:cNvPicPr>
             <a:picLocks noChangeAspect="1"/>
           </p:cNvPicPr>
@@ -7833,8 +8259,8 @@
         </p:blipFill>
         <p:spPr>
           <a:xfrm>
-            <a:off x="3365383" y="1371600"/>
-            <a:ext cx="5460927" cy="4800600"/>
+            <a:off x="2271867" y="1417320"/>
+            <a:ext cx="7647959" cy="4709160"/>
           </a:xfrm>
           <a:prstGeom prst="rect">
             <a:avLst/>
@@ -8009,7 +8435,7 @@
                 </a:solidFill>
                 <a:latin typeface="Calibri"/>
               </a:rPr>
-              <a:t>7 / 16</a:t>
+              <a:t>7 / 17</a:t>
             </a:r>
           </a:p>
         </p:txBody>
@@ -8043,7 +8469,7 @@
                 </a:solidFill>
                 <a:latin typeface="Calibri"/>
               </a:rPr>
-              <a:t>Algorithms / Models / Technical Design</a:t>
+              <a:t>Database / Data Design</a:t>
             </a:r>
           </a:p>
         </p:txBody>
@@ -8056,8 +8482,8 @@
         </p:nvSpPr>
         <p:spPr>
           <a:xfrm>
-            <a:off x="411480" y="1051560"/>
-            <a:ext cx="5943600" cy="4846320"/>
+            <a:off x="457200" y="960120"/>
+            <a:ext cx="11247120" cy="411480"/>
           </a:xfrm>
           <a:prstGeom prst="rect">
             <a:avLst/>
@@ -8070,124 +8496,21 @@
           </a:bodyPr>
           <a:lstStyle/>
           <a:p>
-            <a:pPr>
-              <a:spcAft>
-                <a:spcPts val="1200"/>
-              </a:spcAft>
-            </a:pPr>
-            <a:r>
-              <a:rPr sz="1700" b="1">
-                <a:solidFill>
-                  <a:srgbClr val="102A38"/>
-                </a:solidFill>
-                <a:latin typeface="Calibri"/>
-              </a:rPr>
-              <a:t>•  Auto FX: </a:t>
-            </a:r>
-            <a:r>
-              <a:rPr sz="1700" b="0">
-                <a:solidFill>
-                  <a:srgbClr val="000000"/>
-                </a:solidFill>
-                <a:latin typeface="Calibri"/>
-              </a:rPr>
-              <a:t>foreign unit × exchange rate</a:t>
-            </a:r>
-          </a:p>
-          <a:p>
-            <a:pPr>
-              <a:spcAft>
-                <a:spcPts val="1200"/>
-              </a:spcAft>
-            </a:pPr>
-            <a:r>
-              <a:rPr sz="1700" b="1">
-                <a:solidFill>
-                  <a:srgbClr val="102A38"/>
-                </a:solidFill>
-                <a:latin typeface="Calibri"/>
-              </a:rPr>
-              <a:t>•  Already-Local: </a:t>
-            </a:r>
-            <a:r>
-              <a:rPr sz="1700" b="0">
-                <a:solidFill>
-                  <a:srgbClr val="000000"/>
-                </a:solidFill>
-                <a:latin typeface="Calibri"/>
-              </a:rPr>
-              <a:t>local unit product cost (no Fetch FX required)</a:t>
-            </a:r>
-          </a:p>
-          <a:p>
-            <a:pPr>
-              <a:spcAft>
-                <a:spcPts val="1200"/>
-              </a:spcAft>
-            </a:pPr>
-            <a:r>
-              <a:rPr sz="1700" b="0">
-                <a:solidFill>
-                  <a:srgbClr val="000000"/>
-                </a:solidFill>
-                <a:latin typeface="Calibri"/>
-              </a:rPr>
-              <a:t>•  Allocate shipping / duty / VAT by quantity or weight; compare methods</a:t>
-            </a:r>
-          </a:p>
-          <a:p>
-            <a:pPr>
-              <a:spcAft>
-                <a:spcPts val="1200"/>
-              </a:spcAft>
-            </a:pPr>
-            <a:r>
-              <a:rPr sz="1700" b="0">
-                <a:solidFill>
-                  <a:srgbClr val="000000"/>
-                </a:solidFill>
-                <a:latin typeface="Calibri"/>
-              </a:rPr>
-              <a:t>•  Suggested RP = Landed × (1 + margin)</a:t>
-            </a:r>
-          </a:p>
-          <a:p>
-            <a:pPr>
-              <a:spcAft>
-                <a:spcPts val="1200"/>
-              </a:spcAft>
-            </a:pPr>
-            <a:r>
-              <a:rPr sz="1700" b="0">
-                <a:solidFill>
-                  <a:srgbClr val="000000"/>
-                </a:solidFill>
-                <a:latin typeface="Calibri"/>
-              </a:rPr>
-              <a:t>•  Safety floor = Landed × 1.10 (live on True Cost adjust)</a:t>
-            </a:r>
-          </a:p>
-          <a:p>
-            <a:pPr>
-              <a:spcAft>
-                <a:spcPts val="1200"/>
-              </a:spcAft>
-            </a:pPr>
-            <a:r>
-              <a:rPr sz="1700" b="0">
-                <a:solidFill>
-                  <a:srgbClr val="000000"/>
-                </a:solidFill>
-                <a:latin typeface="Calibri"/>
-              </a:rPr>
-              <a:t>•  UI Auto FX starts at 20 (or last cache); Demo B check uses rate 27.50</a:t>
+            <a:r>
+              <a:rPr sz="1600" b="1">
+                <a:solidFill>
+                  <a:srgbClr val="2A353C"/>
+                </a:solidFill>
+                <a:latin typeface="Calibri"/>
+              </a:rPr>
+              <a:t>UML-style entities · duty/VAT as paperwork totals on the batch · Cost history from ledger · Sale = stock-out only</a:t>
             </a:r>
           </a:p>
         </p:txBody>
       </p:sp>
       <p:pic>
         <p:nvPicPr>
-          <p:cNvPr id="8" name="Picture 7" descr="dual_modes.png"/>
+          <p:cNvPr id="8" name="Picture 7" descr="erd.png"/>
           <p:cNvPicPr>
             <a:picLocks noChangeAspect="1"/>
           </p:cNvPicPr>
@@ -8201,8 +8524,8 @@
         </p:blipFill>
         <p:spPr>
           <a:xfrm>
-            <a:off x="6537960" y="1280160"/>
-            <a:ext cx="5303520" cy="2480147"/>
+            <a:off x="3365383" y="1371600"/>
+            <a:ext cx="5460927" cy="4800600"/>
           </a:xfrm>
           <a:prstGeom prst="rect">
             <a:avLst/>
@@ -8377,7 +8700,7 @@
                 </a:solidFill>
                 <a:latin typeface="Calibri"/>
               </a:rPr>
-              <a:t>8 / 16</a:t>
+              <a:t>8 / 17</a:t>
             </a:r>
           </a:p>
         </p:txBody>
@@ -8411,7 +8734,7 @@
                 </a:solidFill>
                 <a:latin typeface="Calibri"/>
               </a:rPr>
-              <a:t>Development Environment</a:t>
+              <a:t>Algorithms / Models / Technical Design</a:t>
             </a:r>
           </a:p>
         </p:txBody>
@@ -8424,8 +8747,8 @@
         </p:nvSpPr>
         <p:spPr>
           <a:xfrm>
-            <a:off x="548640" y="1051560"/>
-            <a:ext cx="10972800" cy="4754880"/>
+            <a:off x="411480" y="1051560"/>
+            <a:ext cx="5943600" cy="4846320"/>
           </a:xfrm>
           <a:prstGeom prst="rect">
             <a:avLst/>
@@ -8444,22 +8767,22 @@
               </a:spcAft>
             </a:pPr>
             <a:r>
-              <a:rPr sz="1900" b="1">
+              <a:rPr sz="1700" b="1">
                 <a:solidFill>
                   <a:srgbClr val="102A38"/>
                 </a:solidFill>
                 <a:latin typeface="Calibri"/>
               </a:rPr>
-              <a:t>•  Operating system: </a:t>
-            </a:r>
-            <a:r>
-              <a:rPr sz="1900" b="0">
+              <a:t>•  Auto FX: </a:t>
+            </a:r>
+            <a:r>
+              <a:rPr sz="1700" b="0">
                 <a:solidFill>
                   <a:srgbClr val="000000"/>
                 </a:solidFill>
                 <a:latin typeface="Calibri"/>
               </a:rPr>
-              <a:t>Windows 10 / 11</a:t>
+              <a:t>foreign unit × exchange rate</a:t>
             </a:r>
           </a:p>
           <a:p>
@@ -8469,22 +8792,22 @@
               </a:spcAft>
             </a:pPr>
             <a:r>
-              <a:rPr sz="1900" b="1">
+              <a:rPr sz="1700" b="1">
                 <a:solidFill>
                   <a:srgbClr val="102A38"/>
                 </a:solidFill>
                 <a:latin typeface="Calibri"/>
               </a:rPr>
-              <a:t>•  Languages: </a:t>
-            </a:r>
-            <a:r>
-              <a:rPr sz="1900" b="0">
+              <a:t>•  Already-Local: </a:t>
+            </a:r>
+            <a:r>
+              <a:rPr sz="1700" b="0">
                 <a:solidFill>
                   <a:srgbClr val="000000"/>
                 </a:solidFill>
                 <a:latin typeface="Calibri"/>
               </a:rPr>
-              <a:t>Python 3, JavaScript (React)</a:t>
+              <a:t>local unit product cost (no Fetch FX required)</a:t>
             </a:r>
           </a:p>
           <a:p>
@@ -8494,22 +8817,13 @@
               </a:spcAft>
             </a:pPr>
             <a:r>
-              <a:rPr sz="1900" b="1">
-                <a:solidFill>
-                  <a:srgbClr val="102A38"/>
-                </a:solidFill>
-                <a:latin typeface="Calibri"/>
-              </a:rPr>
-              <a:t>•  Frameworks: </a:t>
-            </a:r>
-            <a:r>
-              <a:rPr sz="1900" b="0">
+              <a:rPr sz="1700" b="0">
                 <a:solidFill>
                   <a:srgbClr val="000000"/>
                 </a:solidFill>
                 <a:latin typeface="Calibri"/>
               </a:rPr>
-              <a:t>FastAPI, Vite/React, SQLAlchemy 2, Pydantic</a:t>
+              <a:t>•  Allocate shipping / duty / VAT by quantity or weight; compare methods</a:t>
             </a:r>
           </a:p>
           <a:p>
@@ -8519,22 +8833,13 @@
               </a:spcAft>
             </a:pPr>
             <a:r>
-              <a:rPr sz="1900" b="1">
-                <a:solidFill>
-                  <a:srgbClr val="102A38"/>
-                </a:solidFill>
-                <a:latin typeface="Calibri"/>
-              </a:rPr>
-              <a:t>•  Database: </a:t>
-            </a:r>
-            <a:r>
-              <a:rPr sz="1900" b="0">
+              <a:rPr sz="1700" b="0">
                 <a:solidFill>
                   <a:srgbClr val="000000"/>
                 </a:solidFill>
                 <a:latin typeface="Calibri"/>
               </a:rPr>
-              <a:t>PostgreSQL (primary), SQLite fallback</a:t>
+              <a:t>•  Suggested RP = Landed × (1 + margin)</a:t>
             </a:r>
           </a:p>
           <a:p>
@@ -8544,101 +8849,41 @@
               </a:spcAft>
             </a:pPr>
             <a:r>
-              <a:rPr sz="1900" b="1">
-                <a:solidFill>
-                  <a:srgbClr val="102A38"/>
-                </a:solidFill>
-                <a:latin typeface="Calibri"/>
-              </a:rPr>
-              <a:t>•  FX: </a:t>
-            </a:r>
-            <a:r>
-              <a:rPr sz="1900" b="0">
+              <a:rPr sz="1700" b="0">
                 <a:solidFill>
                   <a:srgbClr val="000000"/>
                 </a:solidFill>
                 <a:latin typeface="Calibri"/>
               </a:rPr>
-              <a:t>Frankfurter / open.er-api + cache / manual</a:t>
-            </a:r>
-          </a:p>
-          <a:p>
-            <a:pPr>
-              <a:spcAft>
-                <a:spcPts val="1200"/>
-              </a:spcAft>
-            </a:pPr>
-            <a:r>
-              <a:rPr sz="1900" b="1">
-                <a:solidFill>
-                  <a:srgbClr val="102A38"/>
-                </a:solidFill>
-                <a:latin typeface="Calibri"/>
-              </a:rPr>
-              <a:t>•  Tools: </a:t>
-            </a:r>
-            <a:r>
-              <a:rPr sz="1900" b="0">
-                <a:solidFill>
-                  <a:srgbClr val="000000"/>
-                </a:solidFill>
-                <a:latin typeface="Calibri"/>
-              </a:rPr>
-              <a:t>VS Code / Cursor, pytest, Git / GitHub</a:t>
-            </a:r>
-          </a:p>
-          <a:p>
-            <a:pPr>
-              <a:spcAft>
-                <a:spcPts val="1200"/>
-              </a:spcAft>
-            </a:pPr>
-            <a:r>
-              <a:rPr sz="1900" b="1">
-                <a:solidFill>
-                  <a:srgbClr val="102A38"/>
-                </a:solidFill>
-                <a:latin typeface="Calibri"/>
-              </a:rPr>
-              <a:t>•  Repository: </a:t>
-            </a:r>
-            <a:r>
-              <a:rPr sz="1900" b="0">
-                <a:solidFill>
-                  <a:srgbClr val="000000"/>
-                </a:solidFill>
-                <a:latin typeface="Calibri"/>
-              </a:rPr>
-              <a:t>https://github.com/Nixon-Shibuchi/Tranz-Algo</a:t>
-            </a:r>
-          </a:p>
-          <a:p>
-            <a:pPr>
-              <a:spcAft>
-                <a:spcPts val="1200"/>
-              </a:spcAft>
-            </a:pPr>
-            <a:r>
-              <a:rPr sz="1900" b="1">
-                <a:solidFill>
-                  <a:srgbClr val="102A38"/>
-                </a:solidFill>
-                <a:latin typeface="Calibri"/>
-              </a:rPr>
-              <a:t>•  Run: </a:t>
-            </a:r>
-            <a:r>
-              <a:rPr sz="1900" b="0">
-                <a:solidFill>
-                  <a:srgbClr val="000000"/>
-                </a:solidFill>
-                <a:latin typeface="Calibri"/>
-              </a:rPr>
-              <a:t>uvicorn :8000 · npm run dev :5173</a:t>
-            </a:r>
-          </a:p>
-        </p:txBody>
-      </p:sp>
+              <a:t>•  Safety floor = Landed × 1.10 (live on True Cost adjust)</a:t>
+            </a:r>
+          </a:p>
+        </p:txBody>
+      </p:sp>
+      <p:pic>
+        <p:nvPicPr>
+          <p:cNvPr id="8" name="Picture 7" descr="dual_modes.png"/>
+          <p:cNvPicPr>
+            <a:picLocks noChangeAspect="1"/>
+          </p:cNvPicPr>
+          <p:nvPr/>
+        </p:nvPicPr>
+        <p:blipFill>
+          <a:blip r:embed="rId2"/>
+          <a:stretch>
+            <a:fillRect/>
+          </a:stretch>
+        </p:blipFill>
+        <p:spPr>
+          <a:xfrm>
+            <a:off x="6537960" y="1280160"/>
+            <a:ext cx="5303520" cy="2480147"/>
+          </a:xfrm>
+          <a:prstGeom prst="rect">
+            <a:avLst/>
+          </a:prstGeom>
+        </p:spPr>
+      </p:pic>
     </p:spTree>
   </p:cSld>
   <p:clrMapOvr>
@@ -8807,7 +9052,7 @@
                 </a:solidFill>
                 <a:latin typeface="Calibri"/>
               </a:rPr>
-              <a:t>9 / 16</a:t>
+              <a:t>9 / 17</a:t>
             </a:r>
           </a:p>
         </p:txBody>
@@ -8841,7 +9086,7 @@
                 </a:solidFill>
                 <a:latin typeface="Calibri"/>
               </a:rPr>
-              <a:t>System Components / Modules</a:t>
+              <a:t>Development Environment</a:t>
             </a:r>
           </a:p>
         </p:txBody>
@@ -8880,7 +9125,7 @@
                 </a:solidFill>
                 <a:latin typeface="Calibri"/>
               </a:rPr>
-              <a:t>•  Auth: </a:t>
+              <a:t>•  Languages: </a:t>
             </a:r>
             <a:r>
               <a:rPr sz="1900" b="0">
@@ -8889,7 +9134,7 @@
                 </a:solidFill>
                 <a:latin typeface="Calibri"/>
               </a:rPr>
-              <a:t>JWT login / Create account</a:t>
+              <a:t>Python 3, JavaScript (React)</a:t>
             </a:r>
           </a:p>
           <a:p>
@@ -8905,7 +9150,7 @@
                 </a:solidFill>
                 <a:latin typeface="Calibri"/>
               </a:rPr>
-              <a:t>•  Products: </a:t>
+              <a:t>•  Frameworks: </a:t>
             </a:r>
             <a:r>
               <a:rPr sz="1900" b="0">
@@ -8914,7 +9159,7 @@
                 </a:solidFill>
                 <a:latin typeface="Calibri"/>
               </a:rPr>
-              <a:t>catalogue + CSV import (+ optional auto SKU)</a:t>
+              <a:t>FastAPI, Vite/React, SQLAlchemy 2, Pydantic</a:t>
             </a:r>
           </a:p>
           <a:p>
@@ -8930,7 +9175,7 @@
                 </a:solidFill>
                 <a:latin typeface="Calibri"/>
               </a:rPr>
-              <a:t>•  Shipments: </a:t>
+              <a:t>•  Database: </a:t>
             </a:r>
             <a:r>
               <a:rPr sz="1900" b="0">
@@ -8939,7 +9184,7 @@
                 </a:solidFill>
                 <a:latin typeface="Calibri"/>
               </a:rPr>
-              <a:t>dual modes, paperwork costs, CSV, Clear drafts</a:t>
+              <a:t>PostgreSQL (primary), SQLite fallback</a:t>
             </a:r>
           </a:p>
           <a:p>
@@ -8955,7 +9200,7 @@
                 </a:solidFill>
                 <a:latin typeface="Calibri"/>
               </a:rPr>
-              <a:t>•  True Cost studio: </a:t>
+              <a:t>•  FX: </a:t>
             </a:r>
             <a:r>
               <a:rPr sz="1900" b="0">
@@ -8964,7 +9209,7 @@
                 </a:solidFill>
                 <a:latin typeface="Calibri"/>
               </a:rPr>
-              <a:t>Lines → Allocate → Price → Commit</a:t>
+              <a:t>Frankfurter / open.er-api + cache / manual</a:t>
             </a:r>
           </a:p>
           <a:p>
@@ -8980,7 +9225,7 @@
                 </a:solidFill>
                 <a:latin typeface="Calibri"/>
               </a:rPr>
-              <a:t>•  FX service: </a:t>
+              <a:t>•  Tools: </a:t>
             </a:r>
             <a:r>
               <a:rPr sz="1900" b="0">
@@ -8989,7 +9234,7 @@
                 </a:solidFill>
                 <a:latin typeface="Calibri"/>
               </a:rPr>
-              <a:t>Fetch / cache / starter 20 / manual</a:t>
+              <a:t>VS Code / Cursor, Git / GitHub</a:t>
             </a:r>
           </a:p>
           <a:p>
@@ -8999,29 +9244,22 @@
               </a:spcAft>
             </a:pPr>
             <a:r>
+              <a:rPr sz="1900" b="1">
+                <a:solidFill>
+                  <a:srgbClr val="102A38"/>
+                </a:solidFill>
+                <a:latin typeface="Calibri"/>
+              </a:rPr>
+              <a:t>•  Repository: </a:t>
+            </a:r>
+            <a:r>
               <a:rPr sz="1900" b="0">
                 <a:solidFill>
                   <a:srgbClr val="000000"/>
                 </a:solidFill>
                 <a:latin typeface="Calibri"/>
               </a:rPr>
-              <a:t>•  Stock board + Record sale (stock-out only — not POS)</a:t>
-            </a:r>
-          </a:p>
-          <a:p>
-            <a:pPr>
-              <a:spcAft>
-                <a:spcPts val="1200"/>
-              </a:spcAft>
-            </a:pPr>
-            <a:r>
-              <a:rPr sz="1900" b="0">
-                <a:solidFill>
-                  <a:srgbClr val="000000"/>
-                </a:solidFill>
-                <a:latin typeface="Calibri"/>
-              </a:rPr>
-              <a:t>•  Dashboard Start fresh + Cost history (When / What)</a:t>
+              <a:t>https://github.com/Nixon-Shibuchi/Tranz-Algo</a:t>
             </a:r>
           </a:p>
         </p:txBody>

</xml_diff>